<commit_message>
fix(eda): alinha arredondamento de assimetria/curtose e 2 correlacoes ao CSV/figura
Auditoria pos-verificacao: assimetria/curtose de agua/esgoto/lixo/razao na Tabela 1 e mediana da razao (2,72) estavam com valores da versao antiga; correlacoes analfab x raca/cor (0,62) e agua x lixo (0,14) e o outlier de analfabetismo (5,2%) agora seguem exatamente a saida do pipeline. Aplicado na apresentacao, no Relatorio de EDA (md+docx) e no de Integridade. Nenhuma interpretacao muda.

Co-Authored-By: Claude Opus 4.8 <noreply@anthropic.com>
</commit_message>
<xml_diff>
--- a/docs/Apresentacoes_IVS/EDA_Fase3_Completa_Revisada_V00001.pptx
+++ b/docs/Apresentacoes_IVS/EDA_Fase3_Completa_Revisada_V00001.pptx
@@ -11450,7 +11450,7 @@
                           <a:ea typeface="Calibri" pitchFamily="34" charset="-122"/>
                           <a:cs typeface="Calibri" pitchFamily="34" charset="-120"/>
                         </a:rPr>
-                        <a:t>5,3%</a:t>
+                        <a:t>5,2%</a:t>
                       </a:r>
                       <a:endParaRPr lang="en-US" sz="1150" dirty="0">
                         <a:latin typeface="Calibri" charset="0"/>
@@ -12306,7 +12306,7 @@
       </p:sp>
       <p:pic>
         <p:nvPicPr>
-          <p:cNvPr id="4" name="Image 0" descr="D:/Iniciação Cientifica/Projeto_IVS_Censo22/.claude/worktrees/hopeful-mclean-e9914e/banco_de_dados/eda/figuras/missing_por_municipio.png">    </p:cNvPr>
+          <p:cNvPr id="4" name="Image 0" descr="D:/Iniciação Cientifica/Projeto_IVS_Censo22/.claude/worktrees/hopeful-mclean-e9914e/banco_de_dados/eda/figuras/missing_por_municipio.png"/>
           <p:cNvPicPr>
             <a:picLocks noChangeAspect="1"/>
           </p:cNvPicPr>
@@ -12796,7 +12796,7 @@
       </p:sp>
       <p:pic>
         <p:nvPicPr>
-          <p:cNvPr id="4" name="Image 0" descr="D:/Iniciação Cientifica/Projeto_IVS_Censo22/.claude/worktrees/hopeful-mclean-e9914e/banco_de_dados/eda/figuras/matriz_correlacao.png">    </p:cNvPr>
+          <p:cNvPr id="4" name="Image 0" descr="D:/Iniciação Cientifica/Projeto_IVS_Censo22/.claude/worktrees/hopeful-mclean-e9914e/banco_de_dados/eda/figuras/matriz_correlacao.png"/>
           <p:cNvPicPr>
             <a:picLocks noChangeAspect="1"/>
           </p:cNvPicPr>
@@ -13073,7 +13073,7 @@
                 <a:ea typeface="Trebuchet MS" pitchFamily="34" charset="-122"/>
                 <a:cs typeface="Trebuchet MS" pitchFamily="34" charset="-120"/>
               </a:rPr>
-              <a:t>+0,63</a:t>
+              <a:t>+0,62</a:t>
             </a:r>
             <a:endParaRPr lang="en-US" sz="1600" dirty="0"/>
           </a:p>
@@ -13823,7 +13823,7 @@
                 <a:ea typeface="Calibri" pitchFamily="34" charset="-122"/>
                 <a:cs typeface="Calibri" pitchFamily="34" charset="-120"/>
               </a:rPr>
-              <a:t>Triângulo mais forte: renda × PPI (−0,81), renda × analfab (−0,75), analfab × PPI (+0,63).</a:t>
+              <a:t>Triângulo mais forte: renda × PPI (−0,81), renda × analfab (−0,75), analfab × PPI (+0,62).</a:t>
             </a:r>
             <a:endParaRPr lang="en-US" sz="1200" dirty="0"/>
           </a:p>
@@ -13979,7 +13979,7 @@
                 <a:ea typeface="Calibri" pitchFamily="34" charset="-122"/>
                 <a:cs typeface="Calibri" pitchFamily="34" charset="-120"/>
               </a:rPr>
-              <a:t>Água, esgoto e lixo — bloco coerente, mas com correlações internas modestas (0,15–0,45).</a:t>
+              <a:t>Água, esgoto e lixo — bloco coerente, mas com correlações internas modestas (0,14–0,45).</a:t>
             </a:r>
             <a:endParaRPr lang="en-US" sz="1200" dirty="0"/>
           </a:p>
@@ -26981,7 +26981,7 @@
                           <a:ea typeface="Calibri" pitchFamily="34" charset="-122"/>
                           <a:cs typeface="Calibri" pitchFamily="34" charset="-120"/>
                         </a:rPr>
-                        <a:t>+8,47</a:t>
+                        <a:t>+8,46</a:t>
                       </a:r>
                       <a:endParaRPr lang="en-US" sz="1100" dirty="0">
                         <a:latin typeface="Calibri" charset="0"/>
@@ -27527,7 +27527,7 @@
                           <a:ea typeface="Calibri" pitchFamily="34" charset="-122"/>
                           <a:cs typeface="Calibri" pitchFamily="34" charset="-120"/>
                         </a:rPr>
-                        <a:t>+2,77</a:t>
+                        <a:t>+2,76</a:t>
                       </a:r>
                       <a:endParaRPr lang="en-US" sz="1100" dirty="0">
                         <a:latin typeface="Calibri" charset="0"/>
@@ -27595,7 +27595,7 @@
                           <a:ea typeface="Calibri" pitchFamily="34" charset="-122"/>
                           <a:cs typeface="Calibri" pitchFamily="34" charset="-120"/>
                         </a:rPr>
-                        <a:t>+6,54</a:t>
+                        <a:t>+6,52</a:t>
                       </a:r>
                       <a:endParaRPr lang="en-US" sz="1100" dirty="0">
                         <a:latin typeface="Calibri" charset="0"/>
@@ -28141,7 +28141,7 @@
                           <a:ea typeface="Calibri" pitchFamily="34" charset="-122"/>
                           <a:cs typeface="Calibri" pitchFamily="34" charset="-120"/>
                         </a:rPr>
-                        <a:t>+2,24</a:t>
+                        <a:t>+2,23</a:t>
                       </a:r>
                       <a:endParaRPr lang="en-US" sz="1100" dirty="0">
                         <a:latin typeface="Calibri" charset="0"/>
@@ -28209,7 +28209,7 @@
                           <a:ea typeface="Calibri" pitchFamily="34" charset="-122"/>
                           <a:cs typeface="Calibri" pitchFamily="34" charset="-120"/>
                         </a:rPr>
-                        <a:t>+3,70</a:t>
+                        <a:t>+3,68</a:t>
                       </a:r>
                       <a:endParaRPr lang="en-US" sz="1100" dirty="0">
                         <a:latin typeface="Calibri" charset="0"/>
@@ -28483,7 +28483,7 @@
                           <a:ea typeface="Calibri" pitchFamily="34" charset="-122"/>
                           <a:cs typeface="Calibri" pitchFamily="34" charset="-120"/>
                         </a:rPr>
-                        <a:t>2,71</a:t>
+                        <a:t>2,72</a:t>
                       </a:r>
                       <a:endParaRPr lang="en-US" sz="1100" dirty="0">
                         <a:latin typeface="Calibri" charset="0"/>
@@ -28755,7 +28755,7 @@
                           <a:ea typeface="Calibri" pitchFamily="34" charset="-122"/>
                           <a:cs typeface="Calibri" pitchFamily="34" charset="-120"/>
                         </a:rPr>
-                        <a:t>+0,08</a:t>
+                        <a:t>+0,09</a:t>
                       </a:r>
                       <a:endParaRPr lang="en-US" sz="1100" dirty="0">
                         <a:latin typeface="Calibri" charset="0"/>
@@ -28823,7 +28823,7 @@
                           <a:ea typeface="Calibri" pitchFamily="34" charset="-122"/>
                           <a:cs typeface="Calibri" pitchFamily="34" charset="-120"/>
                         </a:rPr>
-                        <a:t>+3,91</a:t>
+                        <a:t>+3,90</a:t>
                       </a:r>
                       <a:endParaRPr lang="en-US" sz="1100" dirty="0">
                         <a:latin typeface="Calibri" charset="0"/>
@@ -31113,7 +31113,7 @@
       </p:sp>
       <p:pic>
         <p:nvPicPr>
-          <p:cNvPr id="4" name="Image 0" descr="D:/Iniciação Cientifica/Projeto_IVS_Censo22/.claude/worktrees/hopeful-mclean-e9914e/banco_de_dados/eda/figuras/histogramas.png">    </p:cNvPr>
+          <p:cNvPr id="4" name="Image 0" descr="D:/Iniciação Cientifica/Projeto_IVS_Censo22/.claude/worktrees/hopeful-mclean-e9914e/banco_de_dados/eda/figuras/histogramas.png"/>
           <p:cNvPicPr>
             <a:picLocks noChangeAspect="1"/>
           </p:cNvPicPr>
@@ -31547,7 +31547,7 @@
       </p:sp>
       <p:pic>
         <p:nvPicPr>
-          <p:cNvPr id="4" name="Image 0" descr="D:/Iniciação Cientifica/Projeto_IVS_Censo22/.claude/worktrees/hopeful-mclean-e9914e/banco_de_dados/eda/figuras/boxplots_por_regiao.png">    </p:cNvPr>
+          <p:cNvPr id="4" name="Image 0" descr="D:/Iniciação Cientifica/Projeto_IVS_Censo22/.claude/worktrees/hopeful-mclean-e9914e/banco_de_dados/eda/figuras/boxplots_por_regiao.png"/>
           <p:cNvPicPr>
             <a:picLocks noChangeAspect="1"/>
           </p:cNvPicPr>

</xml_diff>